<commit_message>
docs: update Demo项目教程 and add MCPForUnity offline install option
- Add Git installation step (step 3)
- Add offline MCP installation from local package
- Add new screenshots for Git and offline install
- Update Tutorial-3 pptx with formatting fixes
- Include MCPForUnity source for offline installation

Co-Authored-By: Claude Opus 4.6 <noreply@anthropic.com>
</commit_message>
<xml_diff>
--- a/Tutorial-3/敏捷开发+Superpowers.pptx
+++ b/Tutorial-3/敏捷开发+Superpowers.pptx
@@ -3826,8 +3826,8 @@
           <p:nvPr/>
         </p:nvGraphicFramePr>
         <p:xfrm>
-          <a:off x="4754880" y="3474720"/>
-          <a:ext cx="3931920" cy="1371600"/>
+          <a:off x="5016500" y="269875"/>
+          <a:ext cx="3931920" cy="1828800"/>
         </p:xfrm>
         <a:graphic>
           <a:graphicData uri="http://schemas.openxmlformats.org/drawingml/2006/table">
@@ -4255,6 +4255,163 @@
                 <a:tc>
                   <a:txBody>
                     <a:bodyPr/>
+                    <a:p>
+                      <a:pPr marL="0" indent="0">
+                        <a:buNone/>
+                      </a:pPr>
+                      <a:r>
+                        <a:rPr lang="en-US" sz="1200" dirty="0">
+                          <a:solidFill>
+                            <a:srgbClr val="000000"/>
+                          </a:solidFill>
+                          <a:latin typeface="Calibri" panose="020F0502020204030204" pitchFamily="34" charset="0"/>
+                          <a:ea typeface="Calibri" panose="020F0502020204030204" pitchFamily="34" charset="-122"/>
+                          <a:cs typeface="Calibri" panose="020F0502020204030204" pitchFamily="34" charset="-120"/>
+                        </a:rPr>
+                        <a:t>Level 1</a:t>
+                      </a:r>
+                      <a:endParaRPr lang="en-US" sz="1200" dirty="0">
+                        <a:latin typeface="Calibri" panose="020F0502020204030204" pitchFamily="34" charset="0"/>
+                        <a:ea typeface="Calibri" panose="020F0502020204030204" pitchFamily="34" charset="0"/>
+                        <a:cs typeface="Calibri" panose="020F0502020204030204" pitchFamily="34" charset="0"/>
+                      </a:endParaRPr>
+                    </a:p>
+                  </a:txBody>
+                  <a:tcPr>
+                    <a:lnL w="6350" cap="flat" cmpd="sng" algn="ctr">
+                      <a:solidFill>
+                        <a:srgbClr val="6B7280"/>
+                      </a:solidFill>
+                      <a:prstDash val="solid"/>
+                      <a:round/>
+                      <a:headEnd type="none" w="med" len="med"/>
+                      <a:tailEnd type="none" w="med" len="med"/>
+                    </a:lnL>
+                    <a:lnR w="6350" cap="flat" cmpd="sng" algn="ctr">
+                      <a:solidFill>
+                        <a:srgbClr val="6B7280"/>
+                      </a:solidFill>
+                      <a:prstDash val="solid"/>
+                      <a:round/>
+                      <a:headEnd type="none" w="med" len="med"/>
+                      <a:tailEnd type="none" w="med" len="med"/>
+                    </a:lnR>
+                    <a:lnT w="6350" cap="flat" cmpd="sng" algn="ctr">
+                      <a:solidFill>
+                        <a:srgbClr val="6B7280"/>
+                      </a:solidFill>
+                      <a:prstDash val="solid"/>
+                      <a:round/>
+                      <a:headEnd type="none" w="med" len="med"/>
+                      <a:tailEnd type="none" w="med" len="med"/>
+                    </a:lnT>
+                    <a:lnB w="6350" cap="flat" cmpd="sng" algn="ctr">
+                      <a:solidFill>
+                        <a:srgbClr val="6B7280"/>
+                      </a:solidFill>
+                      <a:prstDash val="solid"/>
+                      <a:round/>
+                      <a:headEnd type="none" w="med" len="med"/>
+                      <a:tailEnd type="none" w="med" len="med"/>
+                    </a:lnB>
+                    <a:solidFill>
+                      <a:srgbClr val="F2F2F2"/>
+                    </a:solidFill>
+                  </a:tcPr>
+                </a:tc>
+                <a:tc>
+                  <a:txBody>
+                    <a:bodyPr/>
+                    <a:p>
+                      <a:pPr marL="0" indent="0">
+                        <a:buNone/>
+                      </a:pPr>
+                      <a:r>
+                        <a:rPr lang="en-US" sz="1200" dirty="0">
+                          <a:latin typeface="Calibri" panose="020F0502020204030204" pitchFamily="34" charset="0"/>
+                          <a:ea typeface="Calibri" panose="020F0502020204030204" pitchFamily="34" charset="0"/>
+                          <a:cs typeface="Calibri" panose="020F0502020204030204" pitchFamily="34" charset="0"/>
+                        </a:rPr>
+                        <a:t>AI</a:t>
+                      </a:r>
+                      <a:r>
+                        <a:rPr lang="zh-CN" altLang="en-US" sz="1200" dirty="0">
+                          <a:latin typeface="Calibri" panose="020F0502020204030204" pitchFamily="34" charset="0"/>
+                          <a:ea typeface="宋体" panose="02010600030101010101" pitchFamily="2" charset="-122"/>
+                          <a:cs typeface="Calibri" panose="020F0502020204030204" pitchFamily="34" charset="0"/>
+                        </a:rPr>
+                        <a:t>询问</a:t>
+                      </a:r>
+                      <a:r>
+                        <a:rPr lang="en-US" altLang="zh-CN" sz="1200" dirty="0">
+                          <a:latin typeface="Calibri" panose="020F0502020204030204" pitchFamily="34" charset="0"/>
+                          <a:ea typeface="宋体" panose="02010600030101010101" pitchFamily="2" charset="-122"/>
+                          <a:cs typeface="Calibri" panose="020F0502020204030204" pitchFamily="34" charset="0"/>
+                        </a:rPr>
+                        <a:t>+</a:t>
+                      </a:r>
+                      <a:r>
+                        <a:rPr lang="zh-CN" altLang="en-US" sz="1200" dirty="0">
+                          <a:latin typeface="Calibri" panose="020F0502020204030204" pitchFamily="34" charset="0"/>
+                          <a:ea typeface="宋体" panose="02010600030101010101" pitchFamily="2" charset="-122"/>
+                          <a:cs typeface="Calibri" panose="020F0502020204030204" pitchFamily="34" charset="0"/>
+                        </a:rPr>
+                        <a:t>查资料</a:t>
+                      </a:r>
+                      <a:endParaRPr lang="zh-CN" altLang="en-US" sz="1200" dirty="0">
+                        <a:latin typeface="Calibri" panose="020F0502020204030204" pitchFamily="34" charset="0"/>
+                        <a:ea typeface="宋体" panose="02010600030101010101" pitchFamily="2" charset="-122"/>
+                        <a:cs typeface="Calibri" panose="020F0502020204030204" pitchFamily="34" charset="0"/>
+                      </a:endParaRPr>
+                    </a:p>
+                  </a:txBody>
+                  <a:tcPr>
+                    <a:lnL w="6350" cap="flat" cmpd="sng" algn="ctr">
+                      <a:solidFill>
+                        <a:srgbClr val="6B7280"/>
+                      </a:solidFill>
+                      <a:prstDash val="solid"/>
+                      <a:round/>
+                      <a:headEnd type="none" w="med" len="med"/>
+                      <a:tailEnd type="none" w="med" len="med"/>
+                    </a:lnL>
+                    <a:lnR w="6350" cap="flat" cmpd="sng" algn="ctr">
+                      <a:solidFill>
+                        <a:srgbClr val="6B7280"/>
+                      </a:solidFill>
+                      <a:prstDash val="solid"/>
+                      <a:round/>
+                      <a:headEnd type="none" w="med" len="med"/>
+                      <a:tailEnd type="none" w="med" len="med"/>
+                    </a:lnR>
+                    <a:lnT w="6350" cap="flat" cmpd="sng" algn="ctr">
+                      <a:solidFill>
+                        <a:srgbClr val="6B7280"/>
+                      </a:solidFill>
+                      <a:prstDash val="solid"/>
+                      <a:round/>
+                      <a:headEnd type="none" w="med" len="med"/>
+                      <a:tailEnd type="none" w="med" len="med"/>
+                    </a:lnT>
+                    <a:lnB w="6350" cap="flat" cmpd="sng" algn="ctr">
+                      <a:solidFill>
+                        <a:srgbClr val="6B7280"/>
+                      </a:solidFill>
+                      <a:prstDash val="solid"/>
+                      <a:round/>
+                      <a:headEnd type="none" w="med" len="med"/>
+                      <a:tailEnd type="none" w="med" len="med"/>
+                    </a:lnB>
+                    <a:solidFill>
+                      <a:srgbClr val="F2F2F2"/>
+                    </a:solidFill>
+                  </a:tcPr>
+                </a:tc>
+              </a:tr>
+              <a:tr h="342900">
+                <a:tc>
+                  <a:txBody>
+                    <a:bodyPr/>
                     <a:lstStyle/>
                     <a:p>
                       <a:pPr marL="0" indent="0">
@@ -4269,7 +4426,7 @@
                           <a:ea typeface="Calibri" panose="020F0502020204030204" pitchFamily="34" charset="-122"/>
                           <a:cs typeface="Calibri" panose="020F0502020204030204" pitchFamily="34" charset="-120"/>
                         </a:rPr>
-                        <a:t>Level 1</a:t>
+                        <a:t>Level 0</a:t>
                       </a:r>
                       <a:endParaRPr lang="en-US" sz="1200" dirty="0">
                         <a:latin typeface="Calibri" panose="020F0502020204030204" pitchFamily="34" charset="0"/>
@@ -6661,12 +6818,20 @@
               <a:buChar char="•"/>
             </a:pPr>
             <a:r>
+              <a:rPr lang="en-US" sz="1600" b="1" dirty="0">
+                <a:solidFill>
+                  <a:srgbClr val="212121"/>
+                </a:solidFill>
+              </a:rPr>
+              <a:t>测试防护网</a:t>
+            </a:r>
+            <a:r>
               <a:rPr lang="en-US" sz="1600" dirty="0">
                 <a:solidFill>
                   <a:srgbClr val="212121"/>
                 </a:solidFill>
               </a:rPr>
-              <a:t>测试防护网 — 提供修改保障，支持重构</a:t>
+              <a:t> — 提供修改保障，支持重构</a:t>
             </a:r>
             <a:endParaRPr lang="en-US" sz="2000" dirty="0"/>
           </a:p>

</xml_diff>